<commit_message>
REL-5 preserve notes backgrounds and namespace aliases
</commit_message>
<xml_diff>
--- a/Tests/RostrumTests/Fixtures/NotesPages/authored-notes.pptx
+++ b/Tests/RostrumTests/Fixtures/NotesPages/authored-notes.pptx
@@ -18,6 +18,11 @@
 <file path=ppt/notesMasters/notesMaster1.xml><?xml version="1.0" encoding="utf-8"?>
 <p:notesMaster xmlns:a="http://schemas.openxmlformats.org/drawingml/2006/main" xmlns:r="http://schemas.openxmlformats.org/officeDocument/2006/relationships" xmlns:p="http://schemas.openxmlformats.org/presentationml/2006/main">
   <p:cSld>
+    <p:bg>
+      <p:bgRef idx="1001">
+        <a:schemeClr val="bg1"/>
+      </p:bgRef>
+    </p:bg>
     <p:spTree>
       <p:nvGrpSpPr>
         <p:cNvPr id="1" name=""/>

</xml_diff>